<commit_message>
Solidify backend and make some updates to frontend
</commit_message>
<xml_diff>
--- a/Diamond_In_The_Rough_Powerpoint.pptx
+++ b/Diamond_In_The_Rough_Powerpoint.pptx
@@ -109,13 +109,18 @@
       </a:defRPr>
     </a:lvl9pPr>
   </p:defaultTextStyle>
+  <p:extLst>
+    <p:ext uri="{EFAFB233-063F-42B5-8137-9DF3F51BA10A}">
+      <p15:sldGuideLst xmlns:p15="http://schemas.microsoft.com/office/powerpoint/2012/main"/>
+    </p:ext>
+  </p:extLst>
 </p:presentation>
 </file>
 
 <file path=ppt/revisionInfo.xml><?xml version="1.0" encoding="utf-8"?>
 <p1510:revInfo xmlns:a="http://schemas.openxmlformats.org/drawingml/2006/main" xmlns:r="http://schemas.openxmlformats.org/officeDocument/2006/relationships" xmlns:p1510="http://schemas.microsoft.com/office/powerpoint/2015/10/main">
   <p1510:revLst>
-    <p1510:client id="{1DD2704D-B1A9-4E31-9439-DA1C69ADD1A8}" v="9" dt="2026-09-27T11:48:09.669"/>
+    <p1510:client id="{1DD2704D-B1A9-4E31-9439-DA1C69ADD1A8}" v="10" dt="2026-09-27T11:53:42.345"/>
   </p1510:revLst>
 </p1510:revInfo>
 </file>
@@ -125,7 +130,7 @@
   <pc:docChgLst>
     <pc:chgData name="Ryan Sippy" userId="9df41c901ed357b2" providerId="LiveId" clId="{D6008333-7F08-4C79-B2F8-B08484620A15}"/>
     <pc:docChg chg="undo custSel addSld modSld">
-      <pc:chgData name="Ryan Sippy" userId="9df41c901ed357b2" providerId="LiveId" clId="{D6008333-7F08-4C79-B2F8-B08484620A15}" dt="2026-09-27T11:51:15.983" v="2647" actId="20577"/>
+      <pc:chgData name="Ryan Sippy" userId="9df41c901ed357b2" providerId="LiveId" clId="{D6008333-7F08-4C79-B2F8-B08484620A15}" dt="2026-09-27T11:53:48.324" v="2684" actId="20577"/>
       <pc:docMkLst>
         <pc:docMk/>
       </pc:docMkLst>
@@ -200,7 +205,7 @@
         </pc:picChg>
       </pc:sldChg>
       <pc:sldChg chg="addSp delSp modSp new mod modClrScheme chgLayout">
-        <pc:chgData name="Ryan Sippy" userId="9df41c901ed357b2" providerId="LiveId" clId="{D6008333-7F08-4C79-B2F8-B08484620A15}" dt="2026-09-27T11:31:15.798" v="849" actId="12"/>
+        <pc:chgData name="Ryan Sippy" userId="9df41c901ed357b2" providerId="LiveId" clId="{D6008333-7F08-4C79-B2F8-B08484620A15}" dt="2026-09-27T11:53:48.324" v="2684" actId="20577"/>
         <pc:sldMkLst>
           <pc:docMk/>
           <pc:sldMk cId="3846775283" sldId="258"/>
@@ -238,7 +243,7 @@
           </ac:spMkLst>
         </pc:spChg>
         <pc:spChg chg="add mod ord">
-          <ac:chgData name="Ryan Sippy" userId="9df41c901ed357b2" providerId="LiveId" clId="{D6008333-7F08-4C79-B2F8-B08484620A15}" dt="2026-09-27T11:31:15.798" v="849" actId="12"/>
+          <ac:chgData name="Ryan Sippy" userId="9df41c901ed357b2" providerId="LiveId" clId="{D6008333-7F08-4C79-B2F8-B08484620A15}" dt="2026-09-27T11:53:48.324" v="2684" actId="20577"/>
           <ac:spMkLst>
             <pc:docMk/>
             <pc:sldMk cId="3846775283" sldId="258"/>
@@ -13132,7 +13137,7 @@
         <p:spPr>
           <a:xfrm>
             <a:off x="5343518" y="2886089"/>
-            <a:ext cx="6315082" cy="3336911"/>
+            <a:ext cx="6710830" cy="3819511"/>
           </a:xfrm>
         </p:spPr>
         <p:txBody>
@@ -13276,6 +13281,24 @@
               <a:rPr lang="en-US" sz="1400" dirty="0"/>
               <a:t> Pages</a:t>
             </a:r>
+          </a:p>
+          <a:p>
+            <a:pPr lvl="1">
+              <a:spcAft>
+                <a:spcPts val="600"/>
+              </a:spcAft>
+              <a:buFont typeface="Arial" panose="020B0604020202020204" pitchFamily="34" charset="0"/>
+              <a:buChar char="•"/>
+            </a:pPr>
+            <a:r>
+              <a:rPr lang="en-US" sz="1400" dirty="0"/>
+              <a:t>Handles state management, daily seed generation, and </a:t>
+            </a:r>
+            <a:r>
+              <a:rPr lang="en-US" sz="1400"/>
+              <a:t>API interactions</a:t>
+            </a:r>
+            <a:endParaRPr lang="en-US" sz="1400" dirty="0"/>
           </a:p>
         </p:txBody>
       </p:sp>

</xml_diff>